<commit_message>
HGB recall max ~96
</commit_message>
<xml_diff>
--- a/reports/fraud_detection_presentation.pptx
+++ b/reports/fraud_detection_presentation.pptx
@@ -16,6 +16,8 @@
     <p:sldId id="264" r:id="rId15"/>
     <p:sldId id="265" r:id="rId16"/>
     <p:sldId id="266" r:id="rId17"/>
+    <p:sldId id="267" r:id="rId18"/>
+    <p:sldId id="268" r:id="rId19"/>
   </p:sldIdLst>
   <p:sldSz cx="9144000" cy="6858000" type="screen4x3"/>
   <p:notesSz cx="6858000" cy="9144000"/>
@@ -3174,6 +3176,132 @@
           <a:lstStyle/>
           <a:p>
             <a:r>
+              <a:t>ROC Curve</a:t>
+            </a:r>
+          </a:p>
+        </p:txBody>
+      </p:sp>
+      <p:pic>
+        <p:nvPicPr>
+          <p:cNvPr id="3" name="Picture 2" descr="roc_curve_models.png"/>
+          <p:cNvPicPr>
+            <a:picLocks noChangeAspect="1"/>
+          </p:cNvPicPr>
+          <p:nvPr/>
+        </p:nvPicPr>
+        <p:blipFill>
+          <a:blip r:embed="rId2"/>
+          <a:stretch>
+            <a:fillRect/>
+          </a:stretch>
+        </p:blipFill>
+        <p:spPr>
+          <a:xfrm>
+            <a:off x="731520" y="1234440"/>
+            <a:ext cx="7680960" cy="5701331"/>
+          </a:xfrm>
+          <a:prstGeom prst="rect">
+            <a:avLst/>
+          </a:prstGeom>
+        </p:spPr>
+      </p:pic>
+    </p:spTree>
+  </p:cSld>
+  <p:clrMapOvr>
+    <a:masterClrMapping/>
+  </p:clrMapOvr>
+</p:sld>
+</file>
+
+<file path=ppt/slides/slide11.xml><?xml version="1.0" encoding="utf-8"?>
+<p:sld xmlns:a="http://schemas.openxmlformats.org/drawingml/2006/main" xmlns:p="http://schemas.openxmlformats.org/presentationml/2006/main" xmlns:r="http://schemas.openxmlformats.org/officeDocument/2006/relationships">
+  <p:cSld>
+    <p:spTree>
+      <p:nvGrpSpPr>
+        <p:cNvPr id="1" name=""/>
+        <p:cNvGrpSpPr/>
+        <p:nvPr/>
+      </p:nvGrpSpPr>
+      <p:grpSpPr/>
+      <p:sp>
+        <p:nvSpPr>
+          <p:cNvPr id="2" name="Title 1"/>
+          <p:cNvSpPr>
+            <a:spLocks noGrp="1"/>
+          </p:cNvSpPr>
+          <p:nvPr>
+            <p:ph type="title"/>
+          </p:nvPr>
+        </p:nvSpPr>
+        <p:spPr/>
+        <p:txBody>
+          <a:bodyPr/>
+          <a:lstStyle/>
+          <a:p>
+            <a:r>
+              <a:t>Precision-Recall Curve</a:t>
+            </a:r>
+          </a:p>
+        </p:txBody>
+      </p:sp>
+      <p:pic>
+        <p:nvPicPr>
+          <p:cNvPr id="3" name="Picture 2" descr="precision_recall_curve_models.png"/>
+          <p:cNvPicPr>
+            <a:picLocks noChangeAspect="1"/>
+          </p:cNvPicPr>
+          <p:nvPr/>
+        </p:nvPicPr>
+        <p:blipFill>
+          <a:blip r:embed="rId2"/>
+          <a:stretch>
+            <a:fillRect/>
+          </a:stretch>
+        </p:blipFill>
+        <p:spPr>
+          <a:xfrm>
+            <a:off x="731520" y="1234440"/>
+            <a:ext cx="7680960" cy="5701331"/>
+          </a:xfrm>
+          <a:prstGeom prst="rect">
+            <a:avLst/>
+          </a:prstGeom>
+        </p:spPr>
+      </p:pic>
+    </p:spTree>
+  </p:cSld>
+  <p:clrMapOvr>
+    <a:masterClrMapping/>
+  </p:clrMapOvr>
+</p:sld>
+</file>
+
+<file path=ppt/slides/slide12.xml><?xml version="1.0" encoding="utf-8"?>
+<p:sld xmlns:a="http://schemas.openxmlformats.org/drawingml/2006/main" xmlns:p="http://schemas.openxmlformats.org/presentationml/2006/main" xmlns:r="http://schemas.openxmlformats.org/officeDocument/2006/relationships">
+  <p:cSld>
+    <p:spTree>
+      <p:nvGrpSpPr>
+        <p:cNvPr id="1" name=""/>
+        <p:cNvGrpSpPr/>
+        <p:nvPr/>
+      </p:nvGrpSpPr>
+      <p:grpSpPr/>
+      <p:sp>
+        <p:nvSpPr>
+          <p:cNvPr id="2" name="Title 1"/>
+          <p:cNvSpPr>
+            <a:spLocks noGrp="1"/>
+          </p:cNvSpPr>
+          <p:nvPr>
+            <p:ph type="title"/>
+          </p:nvPr>
+        </p:nvSpPr>
+        <p:spPr/>
+        <p:txBody>
+          <a:bodyPr/>
+          <a:lstStyle/>
+          <a:p>
+            <a:r>
               <a:t>Confusion Matrix - Random Forest</a:t>
             </a:r>
           </a:p>
@@ -3211,7 +3339,7 @@
 </p:sld>
 </file>
 
-<file path=ppt/slides/slide11.xml><?xml version="1.0" encoding="utf-8"?>
+<file path=ppt/slides/slide13.xml><?xml version="1.0" encoding="utf-8"?>
 <p:sld xmlns:a="http://schemas.openxmlformats.org/drawingml/2006/main" xmlns:p="http://schemas.openxmlformats.org/presentationml/2006/main" xmlns:r="http://schemas.openxmlformats.org/officeDocument/2006/relationships">
   <p:cSld>
     <p:spTree>
@@ -3261,7 +3389,7 @@
               <a:defRPr sz="2200"/>
             </a:pPr>
             <a:r>
-              <a:t>Random Forest achieved the best overall performance.</a:t>
+              <a:t>HistGradientBoosting achieved the best overall performance.</a:t>
             </a:r>
           </a:p>
           <a:p>
@@ -3269,7 +3397,7 @@
               <a:defRPr sz="2200"/>
             </a:pPr>
             <a:r>
-              <a:t>Recall: 0.9147, ROC-AUC: 0.9899.</a:t>
+              <a:t>Recall: 0.9245, F1-score: 0.5137.</a:t>
             </a:r>
           </a:p>
           <a:p>
@@ -3277,7 +3405,15 @@
               <a:defRPr sz="2200"/>
             </a:pPr>
             <a:r>
-              <a:t>High recall is important to reduce missed fraud cases.</a:t>
+              <a:t>ROC-AUC: 0.9976, PR-AUC: 0.8701.</a:t>
+            </a:r>
+          </a:p>
+          <a:p>
+            <a:pPr>
+              <a:defRPr sz="2200"/>
+            </a:pPr>
+            <a:r>
+              <a:t>F1-score improved from Random Forest's 0.3011 to 0.5137.</a:t>
             </a:r>
           </a:p>
           <a:p>
@@ -3465,6 +3601,101 @@
 </file>
 
 <file path=ppt/slides/slide4.xml><?xml version="1.0" encoding="utf-8"?>
+<p:sld xmlns:a="http://schemas.openxmlformats.org/drawingml/2006/main" xmlns:p="http://schemas.openxmlformats.org/presentationml/2006/main" xmlns:r="http://schemas.openxmlformats.org/officeDocument/2006/relationships">
+  <p:cSld>
+    <p:spTree>
+      <p:nvGrpSpPr>
+        <p:cNvPr id="1" name=""/>
+        <p:cNvGrpSpPr/>
+        <p:nvPr/>
+      </p:nvGrpSpPr>
+      <p:grpSpPr/>
+      <p:sp>
+        <p:nvSpPr>
+          <p:cNvPr id="2" name="Title 1"/>
+          <p:cNvSpPr>
+            <a:spLocks noGrp="1"/>
+          </p:cNvSpPr>
+          <p:nvPr>
+            <p:ph type="title"/>
+          </p:nvPr>
+        </p:nvSpPr>
+        <p:spPr/>
+        <p:txBody>
+          <a:bodyPr/>
+          <a:lstStyle/>
+          <a:p>
+            <a:r>
+              <a:t>Big Data 5V Mapping</a:t>
+            </a:r>
+          </a:p>
+        </p:txBody>
+      </p:sp>
+      <p:sp>
+        <p:nvSpPr>
+          <p:cNvPr id="3" name="Content Placeholder 2"/>
+          <p:cNvSpPr>
+            <a:spLocks noGrp="1"/>
+          </p:cNvSpPr>
+          <p:nvPr>
+            <p:ph idx="1"/>
+          </p:nvPr>
+        </p:nvSpPr>
+        <p:spPr/>
+        <p:txBody>
+          <a:bodyPr/>
+          <a:lstStyle/>
+          <a:p>
+            <a:pPr>
+              <a:defRPr sz="2200"/>
+            </a:pPr>
+            <a:r>
+              <a:t>Volume: more than 1.85M transactions across train and test.</a:t>
+            </a:r>
+          </a:p>
+          <a:p>
+            <a:pPr>
+              <a:defRPr sz="2200"/>
+            </a:pPr>
+            <a:r>
+              <a:t>Velocity: financial transactions require fast fraud alerts.</a:t>
+            </a:r>
+          </a:p>
+          <a:p>
+            <a:pPr>
+              <a:defRPr sz="2200"/>
+            </a:pPr>
+            <a:r>
+              <a:t>Variety: amount, time, location, merchant, category and customer profile.</a:t>
+            </a:r>
+          </a:p>
+          <a:p>
+            <a:pPr>
+              <a:defRPr sz="2200"/>
+            </a:pPr>
+            <a:r>
+              <a:t>Veracity: missing/duplicate checks and direct identifier removal.</a:t>
+            </a:r>
+          </a:p>
+          <a:p>
+            <a:pPr>
+              <a:defRPr sz="2200"/>
+            </a:pPr>
+            <a:r>
+              <a:t>Value: fraud detection supports risk reduction and decision making.</a:t>
+            </a:r>
+          </a:p>
+        </p:txBody>
+      </p:sp>
+    </p:spTree>
+  </p:cSld>
+  <p:clrMapOvr>
+    <a:masterClrMapping/>
+  </p:clrMapOvr>
+</p:sld>
+</file>
+
+<file path=ppt/slides/slide5.xml><?xml version="1.0" encoding="utf-8"?>
 <p:sld xmlns:a="http://schemas.openxmlformats.org/drawingml/2006/main" xmlns:p="http://schemas.openxmlformats.org/presentationml/2006/main" xmlns:r="http://schemas.openxmlformats.org/officeDocument/2006/relationships">
   <p:cSld>
     <p:spTree>
@@ -3527,7 +3758,7 @@
 </p:sld>
 </file>
 
-<file path=ppt/slides/slide5.xml><?xml version="1.0" encoding="utf-8"?>
+<file path=ppt/slides/slide6.xml><?xml version="1.0" encoding="utf-8"?>
 <p:sld xmlns:a="http://schemas.openxmlformats.org/drawingml/2006/main" xmlns:p="http://schemas.openxmlformats.org/presentationml/2006/main" xmlns:r="http://schemas.openxmlformats.org/officeDocument/2006/relationships">
   <p:cSld>
     <p:spTree>
@@ -3590,101 +3821,6 @@
 </p:sld>
 </file>
 
-<file path=ppt/slides/slide6.xml><?xml version="1.0" encoding="utf-8"?>
-<p:sld xmlns:a="http://schemas.openxmlformats.org/drawingml/2006/main" xmlns:p="http://schemas.openxmlformats.org/presentationml/2006/main" xmlns:r="http://schemas.openxmlformats.org/officeDocument/2006/relationships">
-  <p:cSld>
-    <p:spTree>
-      <p:nvGrpSpPr>
-        <p:cNvPr id="1" name=""/>
-        <p:cNvGrpSpPr/>
-        <p:nvPr/>
-      </p:nvGrpSpPr>
-      <p:grpSpPr/>
-      <p:sp>
-        <p:nvSpPr>
-          <p:cNvPr id="2" name="Title 1"/>
-          <p:cNvSpPr>
-            <a:spLocks noGrp="1"/>
-          </p:cNvSpPr>
-          <p:nvPr>
-            <p:ph type="title"/>
-          </p:nvPr>
-        </p:nvSpPr>
-        <p:spPr/>
-        <p:txBody>
-          <a:bodyPr/>
-          <a:lstStyle/>
-          <a:p>
-            <a:r>
-              <a:t>Preprocessing</a:t>
-            </a:r>
-          </a:p>
-        </p:txBody>
-      </p:sp>
-      <p:sp>
-        <p:nvSpPr>
-          <p:cNvPr id="3" name="Content Placeholder 2"/>
-          <p:cNvSpPr>
-            <a:spLocks noGrp="1"/>
-          </p:cNvSpPr>
-          <p:nvPr>
-            <p:ph idx="1"/>
-          </p:nvPr>
-        </p:nvSpPr>
-        <p:spPr/>
-        <p:txBody>
-          <a:bodyPr/>
-          <a:lstStyle/>
-          <a:p>
-            <a:pPr>
-              <a:defRPr sz="2200"/>
-            </a:pPr>
-            <a:r>
-              <a:t>Time features: hour, day of week, month, weekend flag.</a:t>
-            </a:r>
-          </a:p>
-          <a:p>
-            <a:pPr>
-              <a:defRPr sz="2200"/>
-            </a:pPr>
-            <a:r>
-              <a:t>Customer age and customer-merchant distance.</a:t>
-            </a:r>
-          </a:p>
-          <a:p>
-            <a:pPr>
-              <a:defRPr sz="2200"/>
-            </a:pPr>
-            <a:r>
-              <a:t>One-hot encoding for category/gender/state.</a:t>
-            </a:r>
-          </a:p>
-          <a:p>
-            <a:pPr>
-              <a:defRPr sz="2200"/>
-            </a:pPr>
-            <a:r>
-              <a:t>Frequency encoding for merchant/job/city.</a:t>
-            </a:r>
-          </a:p>
-          <a:p>
-            <a:pPr>
-              <a:defRPr sz="2200"/>
-            </a:pPr>
-            <a:r>
-              <a:t>Numeric scaling and removal of direct identifiers.</a:t>
-            </a:r>
-          </a:p>
-        </p:txBody>
-      </p:sp>
-    </p:spTree>
-  </p:cSld>
-  <p:clrMapOvr>
-    <a:masterClrMapping/>
-  </p:clrMapOvr>
-</p:sld>
-</file>
-
 <file path=ppt/slides/slide7.xml><?xml version="1.0" encoding="utf-8"?>
 <p:sld xmlns:a="http://schemas.openxmlformats.org/drawingml/2006/main" xmlns:p="http://schemas.openxmlformats.org/presentationml/2006/main" xmlns:r="http://schemas.openxmlformats.org/officeDocument/2006/relationships">
   <p:cSld>
@@ -3711,7 +3847,7 @@
           <a:lstStyle/>
           <a:p>
             <a:r>
-              <a:t>Apache Spark</a:t>
+              <a:t>Preprocessing</a:t>
             </a:r>
           </a:p>
         </p:txBody>
@@ -3735,7 +3871,7 @@
               <a:defRPr sz="2200"/>
             </a:pPr>
             <a:r>
-              <a:t>Read raw train data using Spark DataFrame.</a:t>
+              <a:t>Time features: hour, day of week, month, weekend flag.</a:t>
             </a:r>
           </a:p>
           <a:p>
@@ -3743,7 +3879,7 @@
               <a:defRPr sz="2200"/>
             </a:pPr>
             <a:r>
-              <a:t>Aggregate fraud by category, state, merchant and hour.</a:t>
+              <a:t>Customer age and customer-merchant distance.</a:t>
             </a:r>
           </a:p>
           <a:p>
@@ -3751,7 +3887,7 @@
               <a:defRPr sz="2200"/>
             </a:pPr>
             <a:r>
-              <a:t>Spark version: 3.5.1.</a:t>
+              <a:t>One-hot encoding for category/gender/state.</a:t>
             </a:r>
           </a:p>
           <a:p>
@@ -3759,7 +3895,15 @@
               <a:defRPr sz="2200"/>
             </a:pPr>
             <a:r>
-              <a:t>Pandas vs Spark category aggregation: Spark was faster on this machine.</a:t>
+              <a:t>Frequency encoding for merchant/job/city.</a:t>
+            </a:r>
+          </a:p>
+          <a:p>
+            <a:pPr>
+              <a:defRPr sz="2200"/>
+            </a:pPr>
+            <a:r>
+              <a:t>Numeric scaling and removal of direct identifiers.</a:t>
             </a:r>
           </a:p>
         </p:txBody>
@@ -3773,6 +3917,93 @@
 </file>
 
 <file path=ppt/slides/slide8.xml><?xml version="1.0" encoding="utf-8"?>
+<p:sld xmlns:a="http://schemas.openxmlformats.org/drawingml/2006/main" xmlns:p="http://schemas.openxmlformats.org/presentationml/2006/main" xmlns:r="http://schemas.openxmlformats.org/officeDocument/2006/relationships">
+  <p:cSld>
+    <p:spTree>
+      <p:nvGrpSpPr>
+        <p:cNvPr id="1" name=""/>
+        <p:cNvGrpSpPr/>
+        <p:nvPr/>
+      </p:nvGrpSpPr>
+      <p:grpSpPr/>
+      <p:sp>
+        <p:nvSpPr>
+          <p:cNvPr id="2" name="Title 1"/>
+          <p:cNvSpPr>
+            <a:spLocks noGrp="1"/>
+          </p:cNvSpPr>
+          <p:nvPr>
+            <p:ph type="title"/>
+          </p:nvPr>
+        </p:nvSpPr>
+        <p:spPr/>
+        <p:txBody>
+          <a:bodyPr/>
+          <a:lstStyle/>
+          <a:p>
+            <a:r>
+              <a:t>Apache Spark</a:t>
+            </a:r>
+          </a:p>
+        </p:txBody>
+      </p:sp>
+      <p:sp>
+        <p:nvSpPr>
+          <p:cNvPr id="3" name="Content Placeholder 2"/>
+          <p:cNvSpPr>
+            <a:spLocks noGrp="1"/>
+          </p:cNvSpPr>
+          <p:nvPr>
+            <p:ph idx="1"/>
+          </p:nvPr>
+        </p:nvSpPr>
+        <p:spPr/>
+        <p:txBody>
+          <a:bodyPr/>
+          <a:lstStyle/>
+          <a:p>
+            <a:pPr>
+              <a:defRPr sz="2200"/>
+            </a:pPr>
+            <a:r>
+              <a:t>Read raw train data using Spark DataFrame.</a:t>
+            </a:r>
+          </a:p>
+          <a:p>
+            <a:pPr>
+              <a:defRPr sz="2200"/>
+            </a:pPr>
+            <a:r>
+              <a:t>Aggregate fraud by category, state, merchant and hour.</a:t>
+            </a:r>
+          </a:p>
+          <a:p>
+            <a:pPr>
+              <a:defRPr sz="2200"/>
+            </a:pPr>
+            <a:r>
+              <a:t>Spark version: 3.5.1.</a:t>
+            </a:r>
+          </a:p>
+          <a:p>
+            <a:pPr>
+              <a:defRPr sz="2200"/>
+            </a:pPr>
+            <a:r>
+              <a:t>Pandas vs Spark category aggregation: Spark was faster on this machine.</a:t>
+            </a:r>
+          </a:p>
+        </p:txBody>
+      </p:sp>
+    </p:spTree>
+  </p:cSld>
+  <p:clrMapOvr>
+    <a:masterClrMapping/>
+  </p:clrMapOvr>
+</p:sld>
+</file>
+
+<file path=ppt/slides/slide9.xml><?xml version="1.0" encoding="utf-8"?>
 <p:sld xmlns:a="http://schemas.openxmlformats.org/drawingml/2006/main" xmlns:p="http://schemas.openxmlformats.org/presentationml/2006/main" xmlns:r="http://schemas.openxmlformats.org/officeDocument/2006/relationships">
   <p:cSld>
     <p:spTree>
@@ -3822,14 +4053,15 @@
                 <a:tableStyleId>{5C22544A-7EE6-4342-B048-85BDC9FD1C3A}</a:tableStyleId>
               </a:tblPr>
               <a:tblGrid>
-                <a:gridCol w="1417320"/>
-                <a:gridCol w="1417320"/>
-                <a:gridCol w="1417320"/>
-                <a:gridCol w="1417320"/>
-                <a:gridCol w="1417320"/>
-                <a:gridCol w="1417320"/>
+                <a:gridCol w="1214845"/>
+                <a:gridCol w="1214845"/>
+                <a:gridCol w="1214845"/>
+                <a:gridCol w="1214845"/>
+                <a:gridCol w="1214845"/>
+                <a:gridCol w="1214845"/>
+                <a:gridCol w="1214850"/>
               </a:tblGrid>
-              <a:tr h="548640">
+              <a:tr h="164592">
                 <a:tc>
                   <a:txBody>
                     <a:bodyPr/>
@@ -3848,7 +4080,7 @@
                     <a:lstStyle/>
                     <a:p>
                       <a:r>
-                        <a:t>accuracy</a:t>
+                        <a:t>threshold</a:t>
                       </a:r>
                     </a:p>
                   </a:txBody>
@@ -3902,27 +4134,297 @@
                   </a:txBody>
                   <a:tcPr/>
                 </a:tc>
+                <a:tc>
+                  <a:txBody>
+                    <a:bodyPr/>
+                    <a:lstStyle/>
+                    <a:p>
+                      <a:r>
+                        <a:t>pr_auc</a:t>
+                      </a:r>
+                    </a:p>
+                  </a:txBody>
+                  <a:tcPr/>
+                </a:tc>
               </a:tr>
-              <a:tr h="548640">
-                <a:tc>
-                  <a:txBody>
-                    <a:bodyPr/>
-                    <a:lstStyle/>
-                    <a:p>
-                      <a:r>
-                        <a:t>random_forest</a:t>
-                      </a:r>
-                    </a:p>
-                  </a:txBody>
-                  <a:tcPr/>
-                </a:tc>
-                <a:tc>
-                  <a:txBody>
-                    <a:bodyPr/>
-                    <a:lstStyle/>
-                    <a:p>
-                      <a:r>
-                        <a:t>0.9836</a:t>
+              <a:tr h="164592">
+                <a:tc>
+                  <a:txBody>
+                    <a:bodyPr/>
+                    <a:lstStyle/>
+                    <a:p>
+                      <a:r>
+                        <a:t>hist_gradient_boosting_tuned_f1</a:t>
+                      </a:r>
+                    </a:p>
+                  </a:txBody>
+                  <a:tcPr/>
+                </a:tc>
+                <a:tc>
+                  <a:txBody>
+                    <a:bodyPr/>
+                    <a:lstStyle/>
+                    <a:p>
+                      <a:r>
+                        <a:t>0.8000</a:t>
+                      </a:r>
+                    </a:p>
+                  </a:txBody>
+                  <a:tcPr/>
+                </a:tc>
+                <a:tc>
+                  <a:txBody>
+                    <a:bodyPr/>
+                    <a:lstStyle/>
+                    <a:p>
+                      <a:r>
+                        <a:t>0.3557</a:t>
+                      </a:r>
+                    </a:p>
+                  </a:txBody>
+                  <a:tcPr/>
+                </a:tc>
+                <a:tc>
+                  <a:txBody>
+                    <a:bodyPr/>
+                    <a:lstStyle/>
+                    <a:p>
+                      <a:r>
+                        <a:t>0.9245</a:t>
+                      </a:r>
+                    </a:p>
+                  </a:txBody>
+                  <a:tcPr/>
+                </a:tc>
+                <a:tc>
+                  <a:txBody>
+                    <a:bodyPr/>
+                    <a:lstStyle/>
+                    <a:p>
+                      <a:r>
+                        <a:t>0.5137</a:t>
+                      </a:r>
+                    </a:p>
+                  </a:txBody>
+                  <a:tcPr/>
+                </a:tc>
+                <a:tc>
+                  <a:txBody>
+                    <a:bodyPr/>
+                    <a:lstStyle/>
+                    <a:p>
+                      <a:r>
+                        <a:t>0.9976</a:t>
+                      </a:r>
+                    </a:p>
+                  </a:txBody>
+                  <a:tcPr/>
+                </a:tc>
+                <a:tc>
+                  <a:txBody>
+                    <a:bodyPr/>
+                    <a:lstStyle/>
+                    <a:p>
+                      <a:r>
+                        <a:t>0.8701</a:t>
+                      </a:r>
+                    </a:p>
+                  </a:txBody>
+                  <a:tcPr/>
+                </a:tc>
+              </a:tr>
+              <a:tr h="164592">
+                <a:tc>
+                  <a:txBody>
+                    <a:bodyPr/>
+                    <a:lstStyle/>
+                    <a:p>
+                      <a:r>
+                        <a:t>hist_gradient_boosting_high_recall_0_90</a:t>
+                      </a:r>
+                    </a:p>
+                  </a:txBody>
+                  <a:tcPr/>
+                </a:tc>
+                <a:tc>
+                  <a:txBody>
+                    <a:bodyPr/>
+                    <a:lstStyle/>
+                    <a:p>
+                      <a:r>
+                        <a:t>0.8000</a:t>
+                      </a:r>
+                    </a:p>
+                  </a:txBody>
+                  <a:tcPr/>
+                </a:tc>
+                <a:tc>
+                  <a:txBody>
+                    <a:bodyPr/>
+                    <a:lstStyle/>
+                    <a:p>
+                      <a:r>
+                        <a:t>0.3557</a:t>
+                      </a:r>
+                    </a:p>
+                  </a:txBody>
+                  <a:tcPr/>
+                </a:tc>
+                <a:tc>
+                  <a:txBody>
+                    <a:bodyPr/>
+                    <a:lstStyle/>
+                    <a:p>
+                      <a:r>
+                        <a:t>0.9245</a:t>
+                      </a:r>
+                    </a:p>
+                  </a:txBody>
+                  <a:tcPr/>
+                </a:tc>
+                <a:tc>
+                  <a:txBody>
+                    <a:bodyPr/>
+                    <a:lstStyle/>
+                    <a:p>
+                      <a:r>
+                        <a:t>0.5137</a:t>
+                      </a:r>
+                    </a:p>
+                  </a:txBody>
+                  <a:tcPr/>
+                </a:tc>
+                <a:tc>
+                  <a:txBody>
+                    <a:bodyPr/>
+                    <a:lstStyle/>
+                    <a:p>
+                      <a:r>
+                        <a:t>0.9976</a:t>
+                      </a:r>
+                    </a:p>
+                  </a:txBody>
+                  <a:tcPr/>
+                </a:tc>
+                <a:tc>
+                  <a:txBody>
+                    <a:bodyPr/>
+                    <a:lstStyle/>
+                    <a:p>
+                      <a:r>
+                        <a:t>0.8701</a:t>
+                      </a:r>
+                    </a:p>
+                  </a:txBody>
+                  <a:tcPr/>
+                </a:tc>
+              </a:tr>
+              <a:tr h="164592">
+                <a:tc>
+                  <a:txBody>
+                    <a:bodyPr/>
+                    <a:lstStyle/>
+                    <a:p>
+                      <a:r>
+                        <a:t>hist_gradient_boosting_default_0_50</a:t>
+                      </a:r>
+                    </a:p>
+                  </a:txBody>
+                  <a:tcPr/>
+                </a:tc>
+                <a:tc>
+                  <a:txBody>
+                    <a:bodyPr/>
+                    <a:lstStyle/>
+                    <a:p>
+                      <a:r>
+                        <a:t>0.5000</a:t>
+                      </a:r>
+                    </a:p>
+                  </a:txBody>
+                  <a:tcPr/>
+                </a:tc>
+                <a:tc>
+                  <a:txBody>
+                    <a:bodyPr/>
+                    <a:lstStyle/>
+                    <a:p>
+                      <a:r>
+                        <a:t>0.1938</a:t>
+                      </a:r>
+                    </a:p>
+                  </a:txBody>
+                  <a:tcPr/>
+                </a:tc>
+                <a:tc>
+                  <a:txBody>
+                    <a:bodyPr/>
+                    <a:lstStyle/>
+                    <a:p>
+                      <a:r>
+                        <a:t>0.9669</a:t>
+                      </a:r>
+                    </a:p>
+                  </a:txBody>
+                  <a:tcPr/>
+                </a:tc>
+                <a:tc>
+                  <a:txBody>
+                    <a:bodyPr/>
+                    <a:lstStyle/>
+                    <a:p>
+                      <a:r>
+                        <a:t>0.3229</a:t>
+                      </a:r>
+                    </a:p>
+                  </a:txBody>
+                  <a:tcPr/>
+                </a:tc>
+                <a:tc>
+                  <a:txBody>
+                    <a:bodyPr/>
+                    <a:lstStyle/>
+                    <a:p>
+                      <a:r>
+                        <a:t>0.9976</a:t>
+                      </a:r>
+                    </a:p>
+                  </a:txBody>
+                  <a:tcPr/>
+                </a:tc>
+                <a:tc>
+                  <a:txBody>
+                    <a:bodyPr/>
+                    <a:lstStyle/>
+                    <a:p>
+                      <a:r>
+                        <a:t>0.8701</a:t>
+                      </a:r>
+                    </a:p>
+                  </a:txBody>
+                  <a:tcPr/>
+                </a:tc>
+              </a:tr>
+              <a:tr h="164592">
+                <a:tc>
+                  <a:txBody>
+                    <a:bodyPr/>
+                    <a:lstStyle/>
+                    <a:p>
+                      <a:r>
+                        <a:t>random_forest_default_0_50</a:t>
+                      </a:r>
+                    </a:p>
+                  </a:txBody>
+                  <a:tcPr/>
+                </a:tc>
+                <a:tc>
+                  <a:txBody>
+                    <a:bodyPr/>
+                    <a:lstStyle/>
+                    <a:p>
+                      <a:r>
+                        <a:t>0.5000</a:t>
                       </a:r>
                     </a:p>
                   </a:txBody>
@@ -3976,27 +4478,297 @@
                   </a:txBody>
                   <a:tcPr/>
                 </a:tc>
+                <a:tc>
+                  <a:txBody>
+                    <a:bodyPr/>
+                    <a:lstStyle/>
+                    <a:p>
+                      <a:r>
+                        <a:t>0.7441</a:t>
+                      </a:r>
+                    </a:p>
+                  </a:txBody>
+                  <a:tcPr/>
+                </a:tc>
               </a:tr>
-              <a:tr h="548640">
-                <a:tc>
-                  <a:txBody>
-                    <a:bodyPr/>
-                    <a:lstStyle/>
-                    <a:p>
-                      <a:r>
-                        <a:t>logistic_regression</a:t>
-                      </a:r>
-                    </a:p>
-                  </a:txBody>
-                  <a:tcPr/>
-                </a:tc>
-                <a:tc>
-                  <a:txBody>
-                    <a:bodyPr/>
-                    <a:lstStyle/>
-                    <a:p>
-                      <a:r>
-                        <a:t>0.9393</a:t>
+              <a:tr h="164592">
+                <a:tc>
+                  <a:txBody>
+                    <a:bodyPr/>
+                    <a:lstStyle/>
+                    <a:p>
+                      <a:r>
+                        <a:t>random_forest_tuned_f1</a:t>
+                      </a:r>
+                    </a:p>
+                  </a:txBody>
+                  <a:tcPr/>
+                </a:tc>
+                <a:tc>
+                  <a:txBody>
+                    <a:bodyPr/>
+                    <a:lstStyle/>
+                    <a:p>
+                      <a:r>
+                        <a:t>0.5000</a:t>
+                      </a:r>
+                    </a:p>
+                  </a:txBody>
+                  <a:tcPr/>
+                </a:tc>
+                <a:tc>
+                  <a:txBody>
+                    <a:bodyPr/>
+                    <a:lstStyle/>
+                    <a:p>
+                      <a:r>
+                        <a:t>0.1802</a:t>
+                      </a:r>
+                    </a:p>
+                  </a:txBody>
+                  <a:tcPr/>
+                </a:tc>
+                <a:tc>
+                  <a:txBody>
+                    <a:bodyPr/>
+                    <a:lstStyle/>
+                    <a:p>
+                      <a:r>
+                        <a:t>0.9147</a:t>
+                      </a:r>
+                    </a:p>
+                  </a:txBody>
+                  <a:tcPr/>
+                </a:tc>
+                <a:tc>
+                  <a:txBody>
+                    <a:bodyPr/>
+                    <a:lstStyle/>
+                    <a:p>
+                      <a:r>
+                        <a:t>0.3011</a:t>
+                      </a:r>
+                    </a:p>
+                  </a:txBody>
+                  <a:tcPr/>
+                </a:tc>
+                <a:tc>
+                  <a:txBody>
+                    <a:bodyPr/>
+                    <a:lstStyle/>
+                    <a:p>
+                      <a:r>
+                        <a:t>0.9899</a:t>
+                      </a:r>
+                    </a:p>
+                  </a:txBody>
+                  <a:tcPr/>
+                </a:tc>
+                <a:tc>
+                  <a:txBody>
+                    <a:bodyPr/>
+                    <a:lstStyle/>
+                    <a:p>
+                      <a:r>
+                        <a:t>0.7441</a:t>
+                      </a:r>
+                    </a:p>
+                  </a:txBody>
+                  <a:tcPr/>
+                </a:tc>
+              </a:tr>
+              <a:tr h="164592">
+                <a:tc>
+                  <a:txBody>
+                    <a:bodyPr/>
+                    <a:lstStyle/>
+                    <a:p>
+                      <a:r>
+                        <a:t>random_forest_high_recall_0_90</a:t>
+                      </a:r>
+                    </a:p>
+                  </a:txBody>
+                  <a:tcPr/>
+                </a:tc>
+                <a:tc>
+                  <a:txBody>
+                    <a:bodyPr/>
+                    <a:lstStyle/>
+                    <a:p>
+                      <a:r>
+                        <a:t>0.5000</a:t>
+                      </a:r>
+                    </a:p>
+                  </a:txBody>
+                  <a:tcPr/>
+                </a:tc>
+                <a:tc>
+                  <a:txBody>
+                    <a:bodyPr/>
+                    <a:lstStyle/>
+                    <a:p>
+                      <a:r>
+                        <a:t>0.1802</a:t>
+                      </a:r>
+                    </a:p>
+                  </a:txBody>
+                  <a:tcPr/>
+                </a:tc>
+                <a:tc>
+                  <a:txBody>
+                    <a:bodyPr/>
+                    <a:lstStyle/>
+                    <a:p>
+                      <a:r>
+                        <a:t>0.9147</a:t>
+                      </a:r>
+                    </a:p>
+                  </a:txBody>
+                  <a:tcPr/>
+                </a:tc>
+                <a:tc>
+                  <a:txBody>
+                    <a:bodyPr/>
+                    <a:lstStyle/>
+                    <a:p>
+                      <a:r>
+                        <a:t>0.3011</a:t>
+                      </a:r>
+                    </a:p>
+                  </a:txBody>
+                  <a:tcPr/>
+                </a:tc>
+                <a:tc>
+                  <a:txBody>
+                    <a:bodyPr/>
+                    <a:lstStyle/>
+                    <a:p>
+                      <a:r>
+                        <a:t>0.9899</a:t>
+                      </a:r>
+                    </a:p>
+                  </a:txBody>
+                  <a:tcPr/>
+                </a:tc>
+                <a:tc>
+                  <a:txBody>
+                    <a:bodyPr/>
+                    <a:lstStyle/>
+                    <a:p>
+                      <a:r>
+                        <a:t>0.7441</a:t>
+                      </a:r>
+                    </a:p>
+                  </a:txBody>
+                  <a:tcPr/>
+                </a:tc>
+              </a:tr>
+              <a:tr h="164592">
+                <a:tc>
+                  <a:txBody>
+                    <a:bodyPr/>
+                    <a:lstStyle/>
+                    <a:p>
+                      <a:r>
+                        <a:t>logistic_regression_tuned_f1</a:t>
+                      </a:r>
+                    </a:p>
+                  </a:txBody>
+                  <a:tcPr/>
+                </a:tc>
+                <a:tc>
+                  <a:txBody>
+                    <a:bodyPr/>
+                    <a:lstStyle/>
+                    <a:p>
+                      <a:r>
+                        <a:t>0.7100</a:t>
+                      </a:r>
+                    </a:p>
+                  </a:txBody>
+                  <a:tcPr/>
+                </a:tc>
+                <a:tc>
+                  <a:txBody>
+                    <a:bodyPr/>
+                    <a:lstStyle/>
+                    <a:p>
+                      <a:r>
+                        <a:t>0.1577</a:t>
+                      </a:r>
+                    </a:p>
+                  </a:txBody>
+                  <a:tcPr/>
+                </a:tc>
+                <a:tc>
+                  <a:txBody>
+                    <a:bodyPr/>
+                    <a:lstStyle/>
+                    <a:p>
+                      <a:r>
+                        <a:t>0.6699</a:t>
+                      </a:r>
+                    </a:p>
+                  </a:txBody>
+                  <a:tcPr/>
+                </a:tc>
+                <a:tc>
+                  <a:txBody>
+                    <a:bodyPr/>
+                    <a:lstStyle/>
+                    <a:p>
+                      <a:r>
+                        <a:t>0.2553</a:t>
+                      </a:r>
+                    </a:p>
+                  </a:txBody>
+                  <a:tcPr/>
+                </a:tc>
+                <a:tc>
+                  <a:txBody>
+                    <a:bodyPr/>
+                    <a:lstStyle/>
+                    <a:p>
+                      <a:r>
+                        <a:t>0.9055</a:t>
+                      </a:r>
+                    </a:p>
+                  </a:txBody>
+                  <a:tcPr/>
+                </a:tc>
+                <a:tc>
+                  <a:txBody>
+                    <a:bodyPr/>
+                    <a:lstStyle/>
+                    <a:p>
+                      <a:r>
+                        <a:t>0.1189</a:t>
+                      </a:r>
+                    </a:p>
+                  </a:txBody>
+                  <a:tcPr/>
+                </a:tc>
+              </a:tr>
+              <a:tr h="164592">
+                <a:tc>
+                  <a:txBody>
+                    <a:bodyPr/>
+                    <a:lstStyle/>
+                    <a:p>
+                      <a:r>
+                        <a:t>logistic_regression_default_0_50</a:t>
+                      </a:r>
+                    </a:p>
+                  </a:txBody>
+                  <a:tcPr/>
+                </a:tc>
+                <a:tc>
+                  <a:txBody>
+                    <a:bodyPr/>
+                    <a:lstStyle/>
+                    <a:p>
+                      <a:r>
+                        <a:t>0.5000</a:t>
                       </a:r>
                     </a:p>
                   </a:txBody>
@@ -4045,6 +4817,104 @@
                     <a:p>
                       <a:r>
                         <a:t>0.9055</a:t>
+                      </a:r>
+                    </a:p>
+                  </a:txBody>
+                  <a:tcPr/>
+                </a:tc>
+                <a:tc>
+                  <a:txBody>
+                    <a:bodyPr/>
+                    <a:lstStyle/>
+                    <a:p>
+                      <a:r>
+                        <a:t>0.1189</a:t>
+                      </a:r>
+                    </a:p>
+                  </a:txBody>
+                  <a:tcPr/>
+                </a:tc>
+              </a:tr>
+              <a:tr h="164592">
+                <a:tc>
+                  <a:txBody>
+                    <a:bodyPr/>
+                    <a:lstStyle/>
+                    <a:p>
+                      <a:r>
+                        <a:t>logistic_regression_high_recall_0_90</a:t>
+                      </a:r>
+                    </a:p>
+                  </a:txBody>
+                  <a:tcPr/>
+                </a:tc>
+                <a:tc>
+                  <a:txBody>
+                    <a:bodyPr/>
+                    <a:lstStyle/>
+                    <a:p>
+                      <a:r>
+                        <a:t>0.2700</a:t>
+                      </a:r>
+                    </a:p>
+                  </a:txBody>
+                  <a:tcPr/>
+                </a:tc>
+                <a:tc>
+                  <a:txBody>
+                    <a:bodyPr/>
+                    <a:lstStyle/>
+                    <a:p>
+                      <a:r>
+                        <a:t>0.0124</a:t>
+                      </a:r>
+                    </a:p>
+                  </a:txBody>
+                  <a:tcPr/>
+                </a:tc>
+                <a:tc>
+                  <a:txBody>
+                    <a:bodyPr/>
+                    <a:lstStyle/>
+                    <a:p>
+                      <a:r>
+                        <a:t>0.8149</a:t>
+                      </a:r>
+                    </a:p>
+                  </a:txBody>
+                  <a:tcPr/>
+                </a:tc>
+                <a:tc>
+                  <a:txBody>
+                    <a:bodyPr/>
+                    <a:lstStyle/>
+                    <a:p>
+                      <a:r>
+                        <a:t>0.0243</a:t>
+                      </a:r>
+                    </a:p>
+                  </a:txBody>
+                  <a:tcPr/>
+                </a:tc>
+                <a:tc>
+                  <a:txBody>
+                    <a:bodyPr/>
+                    <a:lstStyle/>
+                    <a:p>
+                      <a:r>
+                        <a:t>0.9055</a:t>
+                      </a:r>
+                    </a:p>
+                  </a:txBody>
+                  <a:tcPr/>
+                </a:tc>
+                <a:tc>
+                  <a:txBody>
+                    <a:bodyPr/>
+                    <a:lstStyle/>
+                    <a:p>
+                      <a:r>
+                        <a:t>0.1189</a:t>
                       </a:r>
                     </a:p>
                   </a:txBody>
@@ -4055,69 +4925,6 @@
           </a:graphicData>
         </a:graphic>
       </p:graphicFrame>
-    </p:spTree>
-  </p:cSld>
-  <p:clrMapOvr>
-    <a:masterClrMapping/>
-  </p:clrMapOvr>
-</p:sld>
-</file>
-
-<file path=ppt/slides/slide9.xml><?xml version="1.0" encoding="utf-8"?>
-<p:sld xmlns:a="http://schemas.openxmlformats.org/drawingml/2006/main" xmlns:p="http://schemas.openxmlformats.org/presentationml/2006/main" xmlns:r="http://schemas.openxmlformats.org/officeDocument/2006/relationships">
-  <p:cSld>
-    <p:spTree>
-      <p:nvGrpSpPr>
-        <p:cNvPr id="1" name=""/>
-        <p:cNvGrpSpPr/>
-        <p:nvPr/>
-      </p:nvGrpSpPr>
-      <p:grpSpPr/>
-      <p:sp>
-        <p:nvSpPr>
-          <p:cNvPr id="2" name="Title 1"/>
-          <p:cNvSpPr>
-            <a:spLocks noGrp="1"/>
-          </p:cNvSpPr>
-          <p:nvPr>
-            <p:ph type="title"/>
-          </p:nvPr>
-        </p:nvSpPr>
-        <p:spPr/>
-        <p:txBody>
-          <a:bodyPr/>
-          <a:lstStyle/>
-          <a:p>
-            <a:r>
-              <a:t>ROC Curve</a:t>
-            </a:r>
-          </a:p>
-        </p:txBody>
-      </p:sp>
-      <p:pic>
-        <p:nvPicPr>
-          <p:cNvPr id="3" name="Picture 2" descr="roc_curve_models.png"/>
-          <p:cNvPicPr>
-            <a:picLocks noChangeAspect="1"/>
-          </p:cNvPicPr>
-          <p:nvPr/>
-        </p:nvPicPr>
-        <p:blipFill>
-          <a:blip r:embed="rId2"/>
-          <a:stretch>
-            <a:fillRect/>
-          </a:stretch>
-        </p:blipFill>
-        <p:spPr>
-          <a:xfrm>
-            <a:off x="731520" y="1234440"/>
-            <a:ext cx="7680960" cy="5701331"/>
-          </a:xfrm>
-          <a:prstGeom prst="rect">
-            <a:avLst/>
-          </a:prstGeom>
-        </p:spPr>
-      </p:pic>
     </p:spTree>
   </p:cSld>
   <p:clrMapOvr>

</xml_diff>